<commit_message>
refactor(pmm-deliverables): rename files to lowercase kebab-case and fix directory typo ux-onboarding
</commit_message>
<xml_diff>
--- a/Author_Profile.pptx
+++ b/Author_Profile.pptx
@@ -111,6 +111,11 @@
       </a:defRPr>
     </a:lvl9pPr>
   </p:defaultTextStyle>
+  <p:extLst>
+    <p:ext uri="{EFAFB233-063F-42B5-8137-9DF3F51BA10A}">
+      <p15:sldGuideLst xmlns:p15="http://schemas.microsoft.com/office/powerpoint/2012/main"/>
+    </p:ext>
+  </p:extLst>
 </p:presentation>
 </file>
 
@@ -1654,7 +1659,7 @@
               <a:defRPr/>
             </a:pPr>
             <a:r>
-              <a:rPr kumimoji="0" lang="en-US" sz="1000" b="0" i="0" u="none" strike="noStrike" kern="1200" cap="none" spc="0" normalizeH="0" baseline="0" noProof="0">
+              <a:rPr kumimoji="0" lang="en-US" sz="1000" b="0" i="0" u="none" strike="noStrike" kern="1200" cap="none" spc="0" normalizeH="0" baseline="0" noProof="0" dirty="0">
                 <a:ln>
                   <a:noFill/>
                 </a:ln>
@@ -1668,7 +1673,7 @@
                 <a:ea typeface="+mn-ea"/>
                 <a:cs typeface="+mn-cs"/>
               </a:rPr>
-              <a:t>12</a:t>
+              <a:t>1</a:t>
             </a:r>
           </a:p>
         </p:txBody>
@@ -3294,7 +3299,7 @@
               <a:defRPr/>
             </a:pPr>
             <a:r>
-              <a:rPr kumimoji="0" lang="en-US" sz="1000" b="0" i="0" u="none" strike="noStrike" kern="1200" cap="none" spc="0" normalizeH="0" baseline="0" noProof="0">
+              <a:rPr kumimoji="0" lang="en-US" sz="1000" b="0" i="0" u="none" strike="noStrike" kern="1200" cap="none" spc="0" normalizeH="0" baseline="0" noProof="0" dirty="0">
                 <a:ln>
                   <a:noFill/>
                 </a:ln>
@@ -3308,7 +3313,7 @@
                 <a:ea typeface="+mn-ea"/>
                 <a:cs typeface="+mn-cs"/>
               </a:rPr>
-              <a:t>13</a:t>
+              <a:t>2</a:t>
             </a:r>
           </a:p>
         </p:txBody>
@@ -5725,22 +5730,28 @@
               <a:defRPr/>
             </a:pPr>
             <a:r>
-              <a:rPr kumimoji="0" lang="en-US" sz="1000" b="0" i="0" u="none" strike="noStrike" kern="1200" cap="none" spc="0" normalizeH="0" baseline="0" noProof="0">
-                <a:ln>
-                  <a:noFill/>
-                </a:ln>
+              <a:rPr lang="en-US" sz="1000" dirty="0">
                 <a:solidFill>
                   <a:srgbClr val="55504A"/>
                 </a:solidFill>
-                <a:effectLst/>
-                <a:uLnTx/>
-                <a:uFillTx/>
                 <a:latin typeface="Arial"/>
-                <a:ea typeface="+mn-ea"/>
-                <a:cs typeface="+mn-cs"/>
-              </a:rPr>
-              <a:t>14</a:t>
-            </a:r>
+              </a:rPr>
+              <a:t>3</a:t>
+            </a:r>
+            <a:endParaRPr kumimoji="0" lang="en-US" sz="1000" b="0" i="0" u="none" strike="noStrike" kern="1200" cap="none" spc="0" normalizeH="0" baseline="0" noProof="0" dirty="0">
+              <a:ln>
+                <a:noFill/>
+              </a:ln>
+              <a:solidFill>
+                <a:srgbClr val="55504A"/>
+              </a:solidFill>
+              <a:effectLst/>
+              <a:uLnTx/>
+              <a:uFillTx/>
+              <a:latin typeface="Arial"/>
+              <a:ea typeface="+mn-ea"/>
+              <a:cs typeface="+mn-cs"/>
+            </a:endParaRPr>
           </a:p>
         </p:txBody>
       </p:sp>
@@ -8577,7 +8588,7 @@
               <a:defRPr/>
             </a:pPr>
             <a:r>
-              <a:rPr kumimoji="0" lang="en-US" sz="1000" b="0" i="0" u="none" strike="noStrike" kern="1200" cap="none" spc="0" normalizeH="0" baseline="0" noProof="0">
+              <a:rPr kumimoji="0" lang="en-US" sz="1000" b="0" i="0" u="none" strike="noStrike" kern="1200" cap="none" spc="0" normalizeH="0" baseline="0" noProof="0" dirty="0">
                 <a:ln>
                   <a:noFill/>
                 </a:ln>
@@ -8591,7 +8602,7 @@
                 <a:ea typeface="+mn-ea"/>
                 <a:cs typeface="+mn-cs"/>
               </a:rPr>
-              <a:t>15</a:t>
+              <a:t>4</a:t>
             </a:r>
           </a:p>
         </p:txBody>
@@ -11106,7 +11117,7 @@
               <a:defRPr/>
             </a:pPr>
             <a:r>
-              <a:rPr kumimoji="0" lang="en-US" sz="1000" b="0" i="0" u="none" strike="noStrike" kern="1200" cap="none" spc="0" normalizeH="0" baseline="0" noProof="0">
+              <a:rPr kumimoji="0" lang="en-US" sz="1000" b="0" i="0" u="none" strike="noStrike" kern="1200" cap="none" spc="0" normalizeH="0" baseline="0" noProof="0" dirty="0">
                 <a:ln>
                   <a:noFill/>
                 </a:ln>
@@ -11120,7 +11131,7 @@
                 <a:ea typeface="+mn-ea"/>
                 <a:cs typeface="+mn-cs"/>
               </a:rPr>
-              <a:t>16</a:t>
+              <a:t>5</a:t>
             </a:r>
           </a:p>
         </p:txBody>

</xml_diff>